<commit_message>
Derive published trade results from canonical data
</commit_message>
<xml_diff>
--- a/docs/deliverables/GalacticSoupTradeDeck.pptx
+++ b/docs/deliverables/GalacticSoupTradeDeck.pptx
@@ -3279,7 +3279,7 @@
           <a:p>
             <a:r>
               <a:t>Architecture trade study at behavioral fidelity
-Three variants, one winner - every number reproducible with runFullAnalysis</a:t>
+Three candidates scored side by side - every number reproducible with runFullAnalysis</a:t>
             </a:r>
           </a:p>
         </p:txBody>
@@ -3392,7 +3392,7 @@
           <a:lstStyle/>
           <a:p>
             <a:r>
-              <a:t>Recommendation</a:t>
+              <a:t>Where this leaves the selection</a:t>
             </a:r>
           </a:p>
         </p:txBody>
@@ -3424,7 +3424,7 @@
                     <a:bodyPr/>
                     <a:p>
                       <a:r>
-                        <a:t>Adopt EverSimmer as the baseline architecture</a:t>
+                        <a:t>No baseline is committed: ADR-035 reopened the selection for team review</a:t>
                       </a:r>
                     </a:p>
                   </a:txBody>
@@ -3474,7 +3474,7 @@
                     <a:bodyPr/>
                     <a:p>
                       <a:r>
-                        <a:t>  wins all four stakeholder scenarios and 98.4% of 5,000 random weightings</a:t>
+                        <a:t>  EverSimmer leads on the merits: wins 3 of 4 named scenarios and 85.5% of 5,000 random weightings</a:t>
                       </a:r>
                     </a:p>
                   </a:txBody>
@@ -3515,7 +3515,7 @@
                     <a:bodyPr/>
                     <a:p>
                       <a:r>
-                        <a:t>  only variant that keeps producing after any single fault (67% retention, Degraded mode)</a:t>
+                        <a:t>  it is the only candidate that clears all 8 formal gates and still produces after any single fault (67% retention)</a:t>
                       </a:r>
                     </a:p>
                   </a:txBody>
@@ -3556,7 +3556,7 @@
                     <a:bodyPr/>
                     <a:p>
                       <a:r>
-                        <a:t>LeanBroth is eliminated, not dead: a better QC bench puts it back over the throughput floor</a:t>
+                        <a:t>LeanBroth remains a descope option, but misses the 200 bph throughput floor</a:t>
                       </a:r>
                     </a:p>
                   </a:txBody>
@@ -3597,7 +3597,7 @@
                     <a:bodyPr/>
                     <a:p>
                       <a:r>
-                        <a:t>HyperCook keeps a niche - 119-second cold start and the highest raw rate - but is now over the power, cost and volume caps</a:t>
+                        <a:t>HyperCook keeps the 119 s cold-start and raw-rate advantages, but fails power, cost and volume</a:t>
                       </a:r>
                     </a:p>
                   </a:txBody>
@@ -3638,7 +3638,7 @@
                     <a:bodyPr/>
                     <a:p>
                       <a:r>
-                        <a:t>Every number regenerates from the repo: runFullAnalysis, seeded Monte Carlo, 72-test suite</a:t>
+                        <a:t>Every number regenerates from the repo: runFullAnalysis for results, runAllTests for evidence</a:t>
                       </a:r>
                     </a:p>
                   </a:txBody>
@@ -4240,7 +4240,7 @@
               <a:tblGrid>
                 <a:gridCol w="5181600"/>
               </a:tblGrid>
-              <a:tr h="870267">
+              <a:tr h="621619">
                 <a:tc>
                   <a:txBody>
                     <a:bodyPr/>
@@ -4290,7 +4290,7 @@
                   </a:tcPr>
                 </a:tc>
               </a:tr>
-              <a:tr h="870267">
+              <a:tr h="621619">
                 <a:tc>
                   <a:txBody>
                     <a:bodyPr/>
@@ -4331,7 +4331,7 @@
                   </a:tcPr>
                 </a:tc>
               </a:tr>
-              <a:tr h="870267">
+              <a:tr h="621619">
                 <a:tc>
                   <a:txBody>
                     <a:bodyPr/>
@@ -4372,7 +4372,7 @@
                   </a:tcPr>
                 </a:tc>
               </a:tr>
-              <a:tr h="870267">
+              <a:tr h="621619">
                 <a:tc>
                   <a:txBody>
                     <a:bodyPr/>
@@ -4413,7 +4413,89 @@
                   </a:tcPr>
                 </a:tc>
               </a:tr>
-              <a:tr h="870267">
+              <a:tr h="621619">
+                <a:tc>
+                  <a:txBody>
+                    <a:bodyPr/>
+                    <a:p>
+                      <a:r>
+                        <a:t>HyperCook: 500.4 kW, 2097.2 kCr, 418.2 m^3</a:t>
+                      </a:r>
+                    </a:p>
+                  </a:txBody>
+                  <a:tcPr>
+                    <a:lnL algn="ctr" cap="flat" cmpd="sng" w="12710">
+                      <a:solidFill>
+                        <a:srgbClr val="000000"/>
+                      </a:solidFill>
+                      <a:prstDash val="solid"/>
+                      <a:round/>
+                      <a:headEnd len="med" type="none" w="med"/>
+                      <a:tailEnd len="med" type="none" w="med"/>
+                    </a:lnL>
+                    <a:lnR algn="ctr" cap="flat" cmpd="sng" w="12710">
+                      <a:solidFill>
+                        <a:srgbClr val="000000"/>
+                      </a:solidFill>
+                      <a:prstDash val="solid"/>
+                      <a:round/>
+                      <a:headEnd len="med" type="none" w="med"/>
+                      <a:tailEnd len="med" type="none" w="med"/>
+                    </a:lnR>
+                    <a:lnB algn="ctr" cap="flat" cmpd="sng" w="12710">
+                      <a:solidFill>
+                        <a:srgbClr val="000000"/>
+                      </a:solidFill>
+                      <a:prstDash val="solid"/>
+                      <a:round/>
+                      <a:headEnd len="med" type="none" w="med"/>
+                      <a:tailEnd len="med" type="none" w="med"/>
+                    </a:lnB>
+                  </a:tcPr>
+                </a:tc>
+              </a:tr>
+              <a:tr h="621619">
+                <a:tc>
+                  <a:txBody>
+                    <a:bodyPr/>
+                    <a:p>
+                      <a:r>
+                        <a:t>HyperCook is over power, cost and volume before anything runs</a:t>
+                      </a:r>
+                    </a:p>
+                  </a:txBody>
+                  <a:tcPr>
+                    <a:lnL algn="ctr" cap="flat" cmpd="sng" w="12710">
+                      <a:solidFill>
+                        <a:srgbClr val="000000"/>
+                      </a:solidFill>
+                      <a:prstDash val="solid"/>
+                      <a:round/>
+                      <a:headEnd len="med" type="none" w="med"/>
+                      <a:tailEnd len="med" type="none" w="med"/>
+                    </a:lnL>
+                    <a:lnR algn="ctr" cap="flat" cmpd="sng" w="12710">
+                      <a:solidFill>
+                        <a:srgbClr val="000000"/>
+                      </a:solidFill>
+                      <a:prstDash val="solid"/>
+                      <a:round/>
+                      <a:headEnd len="med" type="none" w="med"/>
+                      <a:tailEnd len="med" type="none" w="med"/>
+                    </a:lnR>
+                    <a:lnB algn="ctr" cap="flat" cmpd="sng" w="12710">
+                      <a:solidFill>
+                        <a:srgbClr val="000000"/>
+                      </a:solidFill>
+                      <a:prstDash val="solid"/>
+                      <a:round/>
+                      <a:headEnd len="med" type="none" w="med"/>
+                      <a:tailEnd len="med" type="none" w="med"/>
+                    </a:lnB>
+                  </a:tcPr>
+                </a:tc>
+              </a:tr>
+              <a:tr h="621619">
                 <a:tc>
                   <a:txBody>
                     <a:bodyPr/>
@@ -5179,7 +5261,7 @@
                     <a:bodyPr/>
                     <a:p>
                       <a:r>
-                        <a:t>QC scanner (single string)</a:t>
+                        <a:t>InlineQCScanner (serial single-string)</a:t>
                       </a:r>
                     </a:p>
                   </a:txBody>
@@ -5280,7 +5362,7 @@
                     <a:bodyPr/>
                     <a:p>
                       <a:r>
-                        <a:t>Prep station (single string)</a:t>
+                        <a:t>PrepWorkstation (serial single-string)</a:t>
                       </a:r>
                     </a:p>
                   </a:txBody>
@@ -5381,7 +5463,7 @@
                     <a:bodyPr/>
                     <a:p>
                       <a:r>
-                        <a:t>One of three cells</a:t>
+                        <a:t>ProductionCell1 (one of three cells)</a:t>
                       </a:r>
                     </a:p>
                   </a:txBody>
@@ -5611,7 +5693,7 @@
                     <a:bodyPr/>
                     <a:p>
                       <a:r>
-                        <a:t>Eight quantitative requirements as executable Requirements Table rows</a:t>
+                        <a:t>8 quantitative requirements as executable Requirements Table rows</a:t>
                       </a:r>
                     </a:p>
                   </a:txBody>
@@ -5661,7 +5743,7 @@
                     <a:bodyPr/>
                     <a:p>
                       <a:r>
-                        <a:t>Simulated metrics feed the gate; a parallel hand-coded check must agree</a:t>
+                        <a:t>Canonical roll-up and simulation metrics feed the gate</a:t>
                       </a:r>
                     </a:p>
                   </a:txBody>
@@ -5702,7 +5784,7 @@
                     <a:bodyPr/>
                     <a:p>
                       <a:r>
-                        <a:t>Fail any gate and you are excluded from scoring, not ranked lower</a:t>
+                        <a:t>A parallel hand-coded check must agree with every formal verdict</a:t>
                       </a:r>
                     </a:p>
                   </a:txBody>
@@ -5743,7 +5825,7 @@
                     <a:bodyPr/>
                     <a:p>
                       <a:r>
-                        <a:t>An eliminated variant is a finding with a recovery path</a:t>
+                        <a:t>A failed gate stays visible when all three candidates are scored</a:t>
                       </a:r>
                     </a:p>
                   </a:txBody>
@@ -5804,13 +5886,13 @@
                 <a:gridCol w="2590800"/>
                 <a:gridCol w="2590800"/>
               </a:tblGrid>
-              <a:tr h="870267">
+              <a:tr h="725223">
                 <a:tc>
                   <a:txBody>
                     <a:bodyPr/>
                     <a:p>
                       <a:r>
-                        <a:t>Result</a:t>
+                        <a:t>Variant</a:t>
                       </a:r>
                     </a:p>
                   </a:txBody>
@@ -5858,7 +5940,7 @@
                     <a:bodyPr/>
                     <a:p>
                       <a:r>
-                        <a:t/>
+                        <a:t>Formal gate result</a:t>
                       </a:r>
                     </a:p>
                   </a:txBody>
@@ -5893,7 +5975,220 @@
                   </a:tcPr>
                 </a:tc>
               </a:tr>
-              <a:tr h="870267">
+              <a:tr h="725223">
+                <a:tc>
+                  <a:txBody>
+                    <a:bodyPr/>
+                    <a:p>
+                      <a:r>
+                        <a:t>HyperCook</a:t>
+                      </a:r>
+                    </a:p>
+                  </a:txBody>
+                  <a:tcPr>
+                    <a:lnL algn="ctr" cap="flat" cmpd="sng" w="12710">
+                      <a:solidFill>
+                        <a:srgbClr val="000000"/>
+                      </a:solidFill>
+                      <a:prstDash val="solid"/>
+                      <a:round/>
+                      <a:headEnd len="med" type="none" w="med"/>
+                      <a:tailEnd len="med" type="none" w="med"/>
+                    </a:lnL>
+                    <a:lnR algn="ctr" cap="flat" cmpd="sng" w="12710">
+                      <a:solidFill>
+                        <a:srgbClr val="000000"/>
+                      </a:solidFill>
+                      <a:prstDash val="solid"/>
+                      <a:round/>
+                      <a:headEnd len="med" type="none" w="med"/>
+                      <a:tailEnd len="med" type="none" w="med"/>
+                    </a:lnR>
+                    <a:lnB algn="ctr" cap="flat" cmpd="sng" w="12710">
+                      <a:solidFill>
+                        <a:srgbClr val="000000"/>
+                      </a:solidFill>
+                      <a:prstDash val="solid"/>
+                      <a:round/>
+                      <a:headEnd len="med" type="none" w="med"/>
+                      <a:tailEnd len="med" type="none" w="med"/>
+                    </a:lnB>
+                  </a:tcPr>
+                </a:tc>
+                <a:tc>
+                  <a:txBody>
+                    <a:bodyPr/>
+                    <a:p>
+                      <a:r>
+                        <a:t>fails power, cost and volume</a:t>
+                      </a:r>
+                    </a:p>
+                  </a:txBody>
+                  <a:tcPr>
+                    <a:lnR algn="ctr" cap="flat" cmpd="sng" w="12710">
+                      <a:solidFill>
+                        <a:srgbClr val="000000"/>
+                      </a:solidFill>
+                      <a:prstDash val="solid"/>
+                      <a:round/>
+                      <a:headEnd len="med" type="none" w="med"/>
+                      <a:tailEnd len="med" type="none" w="med"/>
+                    </a:lnR>
+                    <a:lnB algn="ctr" cap="flat" cmpd="sng" w="12710">
+                      <a:solidFill>
+                        <a:srgbClr val="000000"/>
+                      </a:solidFill>
+                      <a:prstDash val="solid"/>
+                      <a:round/>
+                      <a:headEnd len="med" type="none" w="med"/>
+                      <a:tailEnd len="med" type="none" w="med"/>
+                    </a:lnB>
+                  </a:tcPr>
+                </a:tc>
+              </a:tr>
+              <a:tr h="725223">
+                <a:tc>
+                  <a:txBody>
+                    <a:bodyPr/>
+                    <a:p>
+                      <a:r>
+                        <a:t>LeanBroth</a:t>
+                      </a:r>
+                    </a:p>
+                  </a:txBody>
+                  <a:tcPr>
+                    <a:lnL algn="ctr" cap="flat" cmpd="sng" w="12710">
+                      <a:solidFill>
+                        <a:srgbClr val="000000"/>
+                      </a:solidFill>
+                      <a:prstDash val="solid"/>
+                      <a:round/>
+                      <a:headEnd len="med" type="none" w="med"/>
+                      <a:tailEnd len="med" type="none" w="med"/>
+                    </a:lnL>
+                    <a:lnR algn="ctr" cap="flat" cmpd="sng" w="12710">
+                      <a:solidFill>
+                        <a:srgbClr val="000000"/>
+                      </a:solidFill>
+                      <a:prstDash val="solid"/>
+                      <a:round/>
+                      <a:headEnd len="med" type="none" w="med"/>
+                      <a:tailEnd len="med" type="none" w="med"/>
+                    </a:lnR>
+                    <a:lnB algn="ctr" cap="flat" cmpd="sng" w="12710">
+                      <a:solidFill>
+                        <a:srgbClr val="000000"/>
+                      </a:solidFill>
+                      <a:prstDash val="solid"/>
+                      <a:round/>
+                      <a:headEnd len="med" type="none" w="med"/>
+                      <a:tailEnd len="med" type="none" w="med"/>
+                    </a:lnB>
+                  </a:tcPr>
+                </a:tc>
+                <a:tc>
+                  <a:txBody>
+                    <a:bodyPr/>
+                    <a:p>
+                      <a:r>
+                        <a:t>fails throughput</a:t>
+                      </a:r>
+                    </a:p>
+                  </a:txBody>
+                  <a:tcPr>
+                    <a:lnR algn="ctr" cap="flat" cmpd="sng" w="12710">
+                      <a:solidFill>
+                        <a:srgbClr val="000000"/>
+                      </a:solidFill>
+                      <a:prstDash val="solid"/>
+                      <a:round/>
+                      <a:headEnd len="med" type="none" w="med"/>
+                      <a:tailEnd len="med" type="none" w="med"/>
+                    </a:lnR>
+                    <a:lnB algn="ctr" cap="flat" cmpd="sng" w="12710">
+                      <a:solidFill>
+                        <a:srgbClr val="000000"/>
+                      </a:solidFill>
+                      <a:prstDash val="solid"/>
+                      <a:round/>
+                      <a:headEnd len="med" type="none" w="med"/>
+                      <a:tailEnd len="med" type="none" w="med"/>
+                    </a:lnB>
+                  </a:tcPr>
+                </a:tc>
+              </a:tr>
+              <a:tr h="725223">
+                <a:tc>
+                  <a:txBody>
+                    <a:bodyPr/>
+                    <a:p>
+                      <a:r>
+                        <a:t>EverSimmer</a:t>
+                      </a:r>
+                    </a:p>
+                  </a:txBody>
+                  <a:tcPr>
+                    <a:lnL algn="ctr" cap="flat" cmpd="sng" w="12710">
+                      <a:solidFill>
+                        <a:srgbClr val="000000"/>
+                      </a:solidFill>
+                      <a:prstDash val="solid"/>
+                      <a:round/>
+                      <a:headEnd len="med" type="none" w="med"/>
+                      <a:tailEnd len="med" type="none" w="med"/>
+                    </a:lnL>
+                    <a:lnR algn="ctr" cap="flat" cmpd="sng" w="12710">
+                      <a:solidFill>
+                        <a:srgbClr val="000000"/>
+                      </a:solidFill>
+                      <a:prstDash val="solid"/>
+                      <a:round/>
+                      <a:headEnd len="med" type="none" w="med"/>
+                      <a:tailEnd len="med" type="none" w="med"/>
+                    </a:lnR>
+                    <a:lnB algn="ctr" cap="flat" cmpd="sng" w="12710">
+                      <a:solidFill>
+                        <a:srgbClr val="000000"/>
+                      </a:solidFill>
+                      <a:prstDash val="solid"/>
+                      <a:round/>
+                      <a:headEnd len="med" type="none" w="med"/>
+                      <a:tailEnd len="med" type="none" w="med"/>
+                    </a:lnB>
+                  </a:tcPr>
+                </a:tc>
+                <a:tc>
+                  <a:txBody>
+                    <a:bodyPr/>
+                    <a:p>
+                      <a:r>
+                        <a:t>compliant on all 8</a:t>
+                      </a:r>
+                    </a:p>
+                  </a:txBody>
+                  <a:tcPr>
+                    <a:lnR algn="ctr" cap="flat" cmpd="sng" w="12710">
+                      <a:solidFill>
+                        <a:srgbClr val="000000"/>
+                      </a:solidFill>
+                      <a:prstDash val="solid"/>
+                      <a:round/>
+                      <a:headEnd len="med" type="none" w="med"/>
+                      <a:tailEnd len="med" type="none" w="med"/>
+                    </a:lnR>
+                    <a:lnB algn="ctr" cap="flat" cmpd="sng" w="12710">
+                      <a:solidFill>
+                        <a:srgbClr val="000000"/>
+                      </a:solidFill>
+                      <a:prstDash val="solid"/>
+                      <a:round/>
+                      <a:headEnd len="med" type="none" w="med"/>
+                      <a:tailEnd len="med" type="none" w="med"/>
+                    </a:lnB>
+                  </a:tcPr>
+                </a:tc>
+              </a:tr>
+              <a:tr h="725223">
                 <a:tc>
                   <a:txBody>
                     <a:bodyPr/>
@@ -5964,149 +6259,7 @@
                   </a:tcPr>
                 </a:tc>
               </a:tr>
-              <a:tr h="870267">
-                <a:tc>
-                  <a:txBody>
-                    <a:bodyPr/>
-                    <a:p>
-                      <a:r>
-                        <a:t>Failing  HyperCook</a:t>
-                      </a:r>
-                    </a:p>
-                  </a:txBody>
-                  <a:tcPr>
-                    <a:lnL algn="ctr" cap="flat" cmpd="sng" w="12710">
-                      <a:solidFill>
-                        <a:srgbClr val="000000"/>
-                      </a:solidFill>
-                      <a:prstDash val="solid"/>
-                      <a:round/>
-                      <a:headEnd len="med" type="none" w="med"/>
-                      <a:tailEnd len="med" type="none" w="med"/>
-                    </a:lnL>
-                    <a:lnR algn="ctr" cap="flat" cmpd="sng" w="12710">
-                      <a:solidFill>
-                        <a:srgbClr val="000000"/>
-                      </a:solidFill>
-                      <a:prstDash val="solid"/>
-                      <a:round/>
-                      <a:headEnd len="med" type="none" w="med"/>
-                      <a:tailEnd len="med" type="none" w="med"/>
-                    </a:lnR>
-                    <a:lnB algn="ctr" cap="flat" cmpd="sng" w="12710">
-                      <a:solidFill>
-                        <a:srgbClr val="000000"/>
-                      </a:solidFill>
-                      <a:prstDash val="solid"/>
-                      <a:round/>
-                      <a:headEnd len="med" type="none" w="med"/>
-                      <a:tailEnd len="med" type="none" w="med"/>
-                    </a:lnB>
-                  </a:tcPr>
-                </a:tc>
-                <a:tc>
-                  <a:txBody>
-                    <a:bodyPr/>
-                    <a:p>
-                      <a:r>
-                        <a:t>Power, Cost, Volume</a:t>
-                      </a:r>
-                    </a:p>
-                  </a:txBody>
-                  <a:tcPr>
-                    <a:lnR algn="ctr" cap="flat" cmpd="sng" w="12710">
-                      <a:solidFill>
-                        <a:srgbClr val="000000"/>
-                      </a:solidFill>
-                      <a:prstDash val="solid"/>
-                      <a:round/>
-                      <a:headEnd len="med" type="none" w="med"/>
-                      <a:tailEnd len="med" type="none" w="med"/>
-                    </a:lnR>
-                    <a:lnB algn="ctr" cap="flat" cmpd="sng" w="12710">
-                      <a:solidFill>
-                        <a:srgbClr val="000000"/>
-                      </a:solidFill>
-                      <a:prstDash val="solid"/>
-                      <a:round/>
-                      <a:headEnd len="med" type="none" w="med"/>
-                      <a:tailEnd len="med" type="none" w="med"/>
-                    </a:lnB>
-                  </a:tcPr>
-                </a:tc>
-              </a:tr>
-              <a:tr h="870267">
-                <a:tc>
-                  <a:txBody>
-                    <a:bodyPr/>
-                    <a:p>
-                      <a:r>
-                        <a:t>Failing  LeanBroth</a:t>
-                      </a:r>
-                    </a:p>
-                  </a:txBody>
-                  <a:tcPr>
-                    <a:lnL algn="ctr" cap="flat" cmpd="sng" w="12710">
-                      <a:solidFill>
-                        <a:srgbClr val="000000"/>
-                      </a:solidFill>
-                      <a:prstDash val="solid"/>
-                      <a:round/>
-                      <a:headEnd len="med" type="none" w="med"/>
-                      <a:tailEnd len="med" type="none" w="med"/>
-                    </a:lnL>
-                    <a:lnR algn="ctr" cap="flat" cmpd="sng" w="12710">
-                      <a:solidFill>
-                        <a:srgbClr val="000000"/>
-                      </a:solidFill>
-                      <a:prstDash val="solid"/>
-                      <a:round/>
-                      <a:headEnd len="med" type="none" w="med"/>
-                      <a:tailEnd len="med" type="none" w="med"/>
-                    </a:lnR>
-                    <a:lnB algn="ctr" cap="flat" cmpd="sng" w="12710">
-                      <a:solidFill>
-                        <a:srgbClr val="000000"/>
-                      </a:solidFill>
-                      <a:prstDash val="solid"/>
-                      <a:round/>
-                      <a:headEnd len="med" type="none" w="med"/>
-                      <a:tailEnd len="med" type="none" w="med"/>
-                    </a:lnB>
-                  </a:tcPr>
-                </a:tc>
-                <a:tc>
-                  <a:txBody>
-                    <a:bodyPr/>
-                    <a:p>
-                      <a:r>
-                        <a:t>Throughput</a:t>
-                      </a:r>
-                    </a:p>
-                  </a:txBody>
-                  <a:tcPr>
-                    <a:lnR algn="ctr" cap="flat" cmpd="sng" w="12710">
-                      <a:solidFill>
-                        <a:srgbClr val="000000"/>
-                      </a:solidFill>
-                      <a:prstDash val="solid"/>
-                      <a:round/>
-                      <a:headEnd len="med" type="none" w="med"/>
-                      <a:tailEnd len="med" type="none" w="med"/>
-                    </a:lnR>
-                    <a:lnB algn="ctr" cap="flat" cmpd="sng" w="12710">
-                      <a:solidFill>
-                        <a:srgbClr val="000000"/>
-                      </a:solidFill>
-                      <a:prstDash val="solid"/>
-                      <a:round/>
-                      <a:headEnd len="med" type="none" w="med"/>
-                      <a:tailEnd len="med" type="none" w="med"/>
-                    </a:lnB>
-                  </a:tcPr>
-                </a:tc>
-              </a:tr>
-              <a:tr h="870267">
+              <a:tr h="725223">
                 <a:tc>
                   <a:txBody>
                     <a:bodyPr/>
@@ -6151,7 +6304,7 @@
                     <a:bodyPr/>
                     <a:p>
                       <a:r>
-                        <a:t>QC bench with reject &lt;= ~1.3% puts LeanBroth back over the floor</a:t>
+                        <a:t>QC reject &lt;= ~1.3% clears the 200 bph floor</a:t>
                       </a:r>
                     </a:p>
                   </a:txBody>
@@ -6313,9 +6466,11 @@
             <a:tbl>
               <a:tblPr bandRow="1" firstRow="1"/>
               <a:tblGrid>
-                <a:gridCol w="1727200"/>
-                <a:gridCol w="1727200"/>
-                <a:gridCol w="1727200"/>
+                <a:gridCol w="1036320"/>
+                <a:gridCol w="1036320"/>
+                <a:gridCol w="1036320"/>
+                <a:gridCol w="1036320"/>
+                <a:gridCol w="1036320"/>
               </a:tblGrid>
               <a:tr h="870267">
                 <a:tc>
@@ -6337,6 +6492,84 @@
                       <a:headEnd len="med" type="none" w="med"/>
                       <a:tailEnd len="med" type="none" w="med"/>
                     </a:lnL>
+                    <a:lnR algn="ctr" cap="flat" cmpd="sng" w="12710">
+                      <a:solidFill>
+                        <a:srgbClr val="000000"/>
+                      </a:solidFill>
+                      <a:prstDash val="solid"/>
+                      <a:round/>
+                      <a:headEnd len="med" type="none" w="med"/>
+                      <a:tailEnd len="med" type="none" w="med"/>
+                    </a:lnR>
+                    <a:lnT algn="ctr" cap="flat" cmpd="sng" w="12710">
+                      <a:solidFill>
+                        <a:srgbClr val="000000"/>
+                      </a:solidFill>
+                      <a:prstDash val="solid"/>
+                      <a:round/>
+                      <a:headEnd len="med" type="none" w="med"/>
+                      <a:tailEnd len="med" type="none" w="med"/>
+                    </a:lnT>
+                    <a:lnB algn="ctr" cap="flat" cmpd="sng" w="12710">
+                      <a:solidFill>
+                        <a:srgbClr val="000000"/>
+                      </a:solidFill>
+                      <a:prstDash val="solid"/>
+                      <a:round/>
+                      <a:headEnd len="med" type="none" w="med"/>
+                      <a:tailEnd len="med" type="none" w="med"/>
+                    </a:lnB>
+                  </a:tcPr>
+                </a:tc>
+                <a:tc>
+                  <a:txBody>
+                    <a:bodyPr/>
+                    <a:p>
+                      <a:r>
+                        <a:t>HyperCook</a:t>
+                      </a:r>
+                    </a:p>
+                  </a:txBody>
+                  <a:tcPr>
+                    <a:lnR algn="ctr" cap="flat" cmpd="sng" w="12710">
+                      <a:solidFill>
+                        <a:srgbClr val="000000"/>
+                      </a:solidFill>
+                      <a:prstDash val="solid"/>
+                      <a:round/>
+                      <a:headEnd len="med" type="none" w="med"/>
+                      <a:tailEnd len="med" type="none" w="med"/>
+                    </a:lnR>
+                    <a:lnT algn="ctr" cap="flat" cmpd="sng" w="12710">
+                      <a:solidFill>
+                        <a:srgbClr val="000000"/>
+                      </a:solidFill>
+                      <a:prstDash val="solid"/>
+                      <a:round/>
+                      <a:headEnd len="med" type="none" w="med"/>
+                      <a:tailEnd len="med" type="none" w="med"/>
+                    </a:lnT>
+                    <a:lnB algn="ctr" cap="flat" cmpd="sng" w="12710">
+                      <a:solidFill>
+                        <a:srgbClr val="000000"/>
+                      </a:solidFill>
+                      <a:prstDash val="solid"/>
+                      <a:round/>
+                      <a:headEnd len="med" type="none" w="med"/>
+                      <a:tailEnd len="med" type="none" w="med"/>
+                    </a:lnB>
+                  </a:tcPr>
+                </a:tc>
+                <a:tc>
+                  <a:txBody>
+                    <a:bodyPr/>
+                    <a:p>
+                      <a:r>
+                        <a:t>LeanBroth</a:t>
+                      </a:r>
+                    </a:p>
+                  </a:txBody>
+                  <a:tcPr>
                     <a:lnR algn="ctr" cap="flat" cmpd="sng" w="12710">
                       <a:solidFill>
                         <a:srgbClr val="000000"/>
@@ -6410,7 +6643,7 @@
                     <a:bodyPr/>
                     <a:p>
                       <a:r>
-                        <a:t>HyperCook</a:t>
+                        <a:t>Winner</a:t>
                       </a:r>
                     </a:p>
                   </a:txBody>
@@ -6490,7 +6723,7 @@
                     <a:bodyPr/>
                     <a:p>
                       <a:r>
-                        <a:t>0.80</a:t>
+                        <a:t>0.35</a:t>
                       </a:r>
                     </a:p>
                   </a:txBody>
@@ -6520,7 +6753,67 @@
                     <a:bodyPr/>
                     <a:p>
                       <a:r>
-                        <a:t>0.20</a:t>
+                        <a:t>0.35</a:t>
+                      </a:r>
+                    </a:p>
+                  </a:txBody>
+                  <a:tcPr>
+                    <a:lnR algn="ctr" cap="flat" cmpd="sng" w="12710">
+                      <a:solidFill>
+                        <a:srgbClr val="000000"/>
+                      </a:solidFill>
+                      <a:prstDash val="solid"/>
+                      <a:round/>
+                      <a:headEnd len="med" type="none" w="med"/>
+                      <a:tailEnd len="med" type="none" w="med"/>
+                    </a:lnR>
+                    <a:lnB algn="ctr" cap="flat" cmpd="sng" w="12710">
+                      <a:solidFill>
+                        <a:srgbClr val="000000"/>
+                      </a:solidFill>
+                      <a:prstDash val="solid"/>
+                      <a:round/>
+                      <a:headEnd len="med" type="none" w="med"/>
+                      <a:tailEnd len="med" type="none" w="med"/>
+                    </a:lnB>
+                  </a:tcPr>
+                </a:tc>
+                <a:tc>
+                  <a:txBody>
+                    <a:bodyPr/>
+                    <a:p>
+                      <a:r>
+                        <a:t>0.69</a:t>
+                      </a:r>
+                    </a:p>
+                  </a:txBody>
+                  <a:tcPr>
+                    <a:lnR algn="ctr" cap="flat" cmpd="sng" w="12710">
+                      <a:solidFill>
+                        <a:srgbClr val="000000"/>
+                      </a:solidFill>
+                      <a:prstDash val="solid"/>
+                      <a:round/>
+                      <a:headEnd len="med" type="none" w="med"/>
+                      <a:tailEnd len="med" type="none" w="med"/>
+                    </a:lnR>
+                    <a:lnB algn="ctr" cap="flat" cmpd="sng" w="12710">
+                      <a:solidFill>
+                        <a:srgbClr val="000000"/>
+                      </a:solidFill>
+                      <a:prstDash val="solid"/>
+                      <a:round/>
+                      <a:headEnd len="med" type="none" w="med"/>
+                      <a:tailEnd len="med" type="none" w="med"/>
+                    </a:lnB>
+                  </a:tcPr>
+                </a:tc>
+                <a:tc>
+                  <a:txBody>
+                    <a:bodyPr/>
+                    <a:p>
+                      <a:r>
+                        <a:t>EverSimmer</a:t>
                       </a:r>
                     </a:p>
                   </a:txBody>
@@ -6591,7 +6884,7 @@
                     <a:bodyPr/>
                     <a:p>
                       <a:r>
-                        <a:t>0.65</a:t>
+                        <a:t>0.47</a:t>
                       </a:r>
                     </a:p>
                   </a:txBody>
@@ -6621,7 +6914,67 @@
                     <a:bodyPr/>
                     <a:p>
                       <a:r>
-                        <a:t>0.35</a:t>
+                        <a:t>0.30</a:t>
+                      </a:r>
+                    </a:p>
+                  </a:txBody>
+                  <a:tcPr>
+                    <a:lnR algn="ctr" cap="flat" cmpd="sng" w="12710">
+                      <a:solidFill>
+                        <a:srgbClr val="000000"/>
+                      </a:solidFill>
+                      <a:prstDash val="solid"/>
+                      <a:round/>
+                      <a:headEnd len="med" type="none" w="med"/>
+                      <a:tailEnd len="med" type="none" w="med"/>
+                    </a:lnR>
+                    <a:lnB algn="ctr" cap="flat" cmpd="sng" w="12710">
+                      <a:solidFill>
+                        <a:srgbClr val="000000"/>
+                      </a:solidFill>
+                      <a:prstDash val="solid"/>
+                      <a:round/>
+                      <a:headEnd len="med" type="none" w="med"/>
+                      <a:tailEnd len="med" type="none" w="med"/>
+                    </a:lnB>
+                  </a:tcPr>
+                </a:tc>
+                <a:tc>
+                  <a:txBody>
+                    <a:bodyPr/>
+                    <a:p>
+                      <a:r>
+                        <a:t>0.60</a:t>
+                      </a:r>
+                    </a:p>
+                  </a:txBody>
+                  <a:tcPr>
+                    <a:lnR algn="ctr" cap="flat" cmpd="sng" w="12710">
+                      <a:solidFill>
+                        <a:srgbClr val="000000"/>
+                      </a:solidFill>
+                      <a:prstDash val="solid"/>
+                      <a:round/>
+                      <a:headEnd len="med" type="none" w="med"/>
+                      <a:tailEnd len="med" type="none" w="med"/>
+                    </a:lnR>
+                    <a:lnB algn="ctr" cap="flat" cmpd="sng" w="12710">
+                      <a:solidFill>
+                        <a:srgbClr val="000000"/>
+                      </a:solidFill>
+                      <a:prstDash val="solid"/>
+                      <a:round/>
+                      <a:headEnd len="med" type="none" w="med"/>
+                      <a:tailEnd len="med" type="none" w="med"/>
+                    </a:lnB>
+                  </a:tcPr>
+                </a:tc>
+                <a:tc>
+                  <a:txBody>
+                    <a:bodyPr/>
+                    <a:p>
+                      <a:r>
+                        <a:t>EverSimmer</a:t>
                       </a:r>
                     </a:p>
                   </a:txBody>
@@ -6692,7 +7045,7 @@
                     <a:bodyPr/>
                     <a:p>
                       <a:r>
-                        <a:t>0.90</a:t>
+                        <a:t>0.20</a:t>
                       </a:r>
                     </a:p>
                   </a:txBody>
@@ -6722,7 +7075,67 @@
                     <a:bodyPr/>
                     <a:p>
                       <a:r>
-                        <a:t>0.10</a:t>
+                        <a:t>0.61</a:t>
+                      </a:r>
+                    </a:p>
+                  </a:txBody>
+                  <a:tcPr>
+                    <a:lnR algn="ctr" cap="flat" cmpd="sng" w="12710">
+                      <a:solidFill>
+                        <a:srgbClr val="000000"/>
+                      </a:solidFill>
+                      <a:prstDash val="solid"/>
+                      <a:round/>
+                      <a:headEnd len="med" type="none" w="med"/>
+                      <a:tailEnd len="med" type="none" w="med"/>
+                    </a:lnR>
+                    <a:lnB algn="ctr" cap="flat" cmpd="sng" w="12710">
+                      <a:solidFill>
+                        <a:srgbClr val="000000"/>
+                      </a:solidFill>
+                      <a:prstDash val="solid"/>
+                      <a:round/>
+                      <a:headEnd len="med" type="none" w="med"/>
+                      <a:tailEnd len="med" type="none" w="med"/>
+                    </a:lnB>
+                  </a:tcPr>
+                </a:tc>
+                <a:tc>
+                  <a:txBody>
+                    <a:bodyPr/>
+                    <a:p>
+                      <a:r>
+                        <a:t>0.53</a:t>
+                      </a:r>
+                    </a:p>
+                  </a:txBody>
+                  <a:tcPr>
+                    <a:lnR algn="ctr" cap="flat" cmpd="sng" w="12710">
+                      <a:solidFill>
+                        <a:srgbClr val="000000"/>
+                      </a:solidFill>
+                      <a:prstDash val="solid"/>
+                      <a:round/>
+                      <a:headEnd len="med" type="none" w="med"/>
+                      <a:tailEnd len="med" type="none" w="med"/>
+                    </a:lnR>
+                    <a:lnB algn="ctr" cap="flat" cmpd="sng" w="12710">
+                      <a:solidFill>
+                        <a:srgbClr val="000000"/>
+                      </a:solidFill>
+                      <a:prstDash val="solid"/>
+                      <a:round/>
+                      <a:headEnd len="med" type="none" w="med"/>
+                      <a:tailEnd len="med" type="none" w="med"/>
+                    </a:lnB>
+                  </a:tcPr>
+                </a:tc>
+                <a:tc>
+                  <a:txBody>
+                    <a:bodyPr/>
+                    <a:p>
+                      <a:r>
+                        <a:t>LeanBroth</a:t>
                       </a:r>
                     </a:p>
                   </a:txBody>
@@ -6793,7 +7206,7 @@
                     <a:bodyPr/>
                     <a:p>
                       <a:r>
-                        <a:t>0.90</a:t>
+                        <a:t>0.25</a:t>
                       </a:r>
                     </a:p>
                   </a:txBody>
@@ -6823,7 +7236,67 @@
                     <a:bodyPr/>
                     <a:p>
                       <a:r>
-                        <a:t>0.10</a:t>
+                        <a:t>0.31</a:t>
+                      </a:r>
+                    </a:p>
+                  </a:txBody>
+                  <a:tcPr>
+                    <a:lnR algn="ctr" cap="flat" cmpd="sng" w="12710">
+                      <a:solidFill>
+                        <a:srgbClr val="000000"/>
+                      </a:solidFill>
+                      <a:prstDash val="solid"/>
+                      <a:round/>
+                      <a:headEnd len="med" type="none" w="med"/>
+                      <a:tailEnd len="med" type="none" w="med"/>
+                    </a:lnR>
+                    <a:lnB algn="ctr" cap="flat" cmpd="sng" w="12710">
+                      <a:solidFill>
+                        <a:srgbClr val="000000"/>
+                      </a:solidFill>
+                      <a:prstDash val="solid"/>
+                      <a:round/>
+                      <a:headEnd len="med" type="none" w="med"/>
+                      <a:tailEnd len="med" type="none" w="med"/>
+                    </a:lnB>
+                  </a:tcPr>
+                </a:tc>
+                <a:tc>
+                  <a:txBody>
+                    <a:bodyPr/>
+                    <a:p>
+                      <a:r>
+                        <a:t>0.82</a:t>
+                      </a:r>
+                    </a:p>
+                  </a:txBody>
+                  <a:tcPr>
+                    <a:lnR algn="ctr" cap="flat" cmpd="sng" w="12710">
+                      <a:solidFill>
+                        <a:srgbClr val="000000"/>
+                      </a:solidFill>
+                      <a:prstDash val="solid"/>
+                      <a:round/>
+                      <a:headEnd len="med" type="none" w="med"/>
+                      <a:tailEnd len="med" type="none" w="med"/>
+                    </a:lnR>
+                    <a:lnB algn="ctr" cap="flat" cmpd="sng" w="12710">
+                      <a:solidFill>
+                        <a:srgbClr val="000000"/>
+                      </a:solidFill>
+                      <a:prstDash val="solid"/>
+                      <a:round/>
+                      <a:headEnd len="med" type="none" w="med"/>
+                      <a:tailEnd len="med" type="none" w="med"/>
+                    </a:lnB>
+                  </a:tcPr>
+                </a:tc>
+                <a:tc>
+                  <a:txBody>
+                    <a:bodyPr/>
+                    <a:p>
+                      <a:r>
+                        <a:t>EverSimmer</a:t>
                       </a:r>
                     </a:p>
                   </a:txBody>

</xml_diff>